<commit_message>
SE AGREGO SP PARA REORTE DE RECHAZOS Y MODIFICACIONES SOLICITADOS POR CALIDAD 8D
</commit_message>
<xml_diff>
--- a/50_RECHAZOS/Docs/[QC] Reporte Material Rechazado.pptx
+++ b/50_RECHAZOS/Docs/[QC] Reporte Material Rechazado.pptx
@@ -209,7 +209,7 @@
           <a:p>
             <a:fld id="{A17B1792-3256-4E77-8442-3E205CD69EF5}" type="datetimeFigureOut">
               <a:rPr lang="en-US" smtClean="0"/>
-              <a:t>9/3/2021</a:t>
+              <a:t>9/6/2021</a:t>
             </a:fld>
             <a:endParaRPr lang="en-US"/>
           </a:p>
@@ -655,7 +655,7 @@
           <a:p>
             <a:fld id="{07558649-2619-44F9-8F30-2D6466E57529}" type="datetimeFigureOut">
               <a:rPr lang="en-US" smtClean="0"/>
-              <a:t>9/3/2021</a:t>
+              <a:t>9/6/2021</a:t>
             </a:fld>
             <a:endParaRPr lang="en-US"/>
           </a:p>
@@ -823,7 +823,7 @@
           <a:p>
             <a:fld id="{07558649-2619-44F9-8F30-2D6466E57529}" type="datetimeFigureOut">
               <a:rPr lang="en-US" smtClean="0"/>
-              <a:t>9/3/2021</a:t>
+              <a:t>9/6/2021</a:t>
             </a:fld>
             <a:endParaRPr lang="en-US"/>
           </a:p>
@@ -1001,7 +1001,7 @@
           <a:p>
             <a:fld id="{07558649-2619-44F9-8F30-2D6466E57529}" type="datetimeFigureOut">
               <a:rPr lang="en-US" smtClean="0"/>
-              <a:t>9/3/2021</a:t>
+              <a:t>9/6/2021</a:t>
             </a:fld>
             <a:endParaRPr lang="en-US"/>
           </a:p>
@@ -1169,7 +1169,7 @@
           <a:p>
             <a:fld id="{07558649-2619-44F9-8F30-2D6466E57529}" type="datetimeFigureOut">
               <a:rPr lang="en-US" smtClean="0"/>
-              <a:t>9/3/2021</a:t>
+              <a:t>9/6/2021</a:t>
             </a:fld>
             <a:endParaRPr lang="en-US"/>
           </a:p>
@@ -1414,7 +1414,7 @@
           <a:p>
             <a:fld id="{07558649-2619-44F9-8F30-2D6466E57529}" type="datetimeFigureOut">
               <a:rPr lang="en-US" smtClean="0"/>
-              <a:t>9/3/2021</a:t>
+              <a:t>9/6/2021</a:t>
             </a:fld>
             <a:endParaRPr lang="en-US"/>
           </a:p>
@@ -1699,7 +1699,7 @@
           <a:p>
             <a:fld id="{07558649-2619-44F9-8F30-2D6466E57529}" type="datetimeFigureOut">
               <a:rPr lang="en-US" smtClean="0"/>
-              <a:t>9/3/2021</a:t>
+              <a:t>9/6/2021</a:t>
             </a:fld>
             <a:endParaRPr lang="en-US"/>
           </a:p>
@@ -2118,7 +2118,7 @@
           <a:p>
             <a:fld id="{07558649-2619-44F9-8F30-2D6466E57529}" type="datetimeFigureOut">
               <a:rPr lang="en-US" smtClean="0"/>
-              <a:t>9/3/2021</a:t>
+              <a:t>9/6/2021</a:t>
             </a:fld>
             <a:endParaRPr lang="en-US"/>
           </a:p>
@@ -2235,7 +2235,7 @@
           <a:p>
             <a:fld id="{07558649-2619-44F9-8F30-2D6466E57529}" type="datetimeFigureOut">
               <a:rPr lang="en-US" smtClean="0"/>
-              <a:t>9/3/2021</a:t>
+              <a:t>9/6/2021</a:t>
             </a:fld>
             <a:endParaRPr lang="en-US"/>
           </a:p>
@@ -2330,7 +2330,7 @@
           <a:p>
             <a:fld id="{07558649-2619-44F9-8F30-2D6466E57529}" type="datetimeFigureOut">
               <a:rPr lang="en-US" smtClean="0"/>
-              <a:t>9/3/2021</a:t>
+              <a:t>9/6/2021</a:t>
             </a:fld>
             <a:endParaRPr lang="en-US"/>
           </a:p>
@@ -2605,7 +2605,7 @@
           <a:p>
             <a:fld id="{07558649-2619-44F9-8F30-2D6466E57529}" type="datetimeFigureOut">
               <a:rPr lang="en-US" smtClean="0"/>
-              <a:t>9/3/2021</a:t>
+              <a:t>9/6/2021</a:t>
             </a:fld>
             <a:endParaRPr lang="en-US"/>
           </a:p>
@@ -2857,7 +2857,7 @@
           <a:p>
             <a:fld id="{07558649-2619-44F9-8F30-2D6466E57529}" type="datetimeFigureOut">
               <a:rPr lang="en-US" smtClean="0"/>
-              <a:t>9/3/2021</a:t>
+              <a:t>9/6/2021</a:t>
             </a:fld>
             <a:endParaRPr lang="en-US"/>
           </a:p>
@@ -3077,7 +3077,7 @@
           <a:p>
             <a:fld id="{07558649-2619-44F9-8F30-2D6466E57529}" type="datetimeFigureOut">
               <a:rPr lang="en-US" smtClean="0"/>
-              <a:t>9/3/2021</a:t>
+              <a:t>9/6/2021</a:t>
             </a:fld>
             <a:endParaRPr lang="en-US"/>
           </a:p>
@@ -3494,7 +3494,7 @@
               <a:rPr lang="es-MX" b="1" dirty="0">
                 <a:latin typeface="Century Gothic" panose="020B0502020202020204" pitchFamily="34" charset="0"/>
               </a:rPr>
-              <a:t>05/07/2021 – 09/07/2021</a:t>
+              <a:t>30/08/2021 – 03/09/2021</a:t>
             </a:r>
             <a:endParaRPr lang="es-MX" dirty="0">
               <a:latin typeface="Century Gothic" panose="020B0502020202020204" pitchFamily="34" charset="0"/>
@@ -3575,7 +3575,7 @@
                   <a:srgbClr val="3F1900"/>
                 </a:solidFill>
               </a:rPr>
-              <a:t>Seguimiento de Material Programado.</a:t>
+              <a:t>Reporte de Rechazos.</a:t>
             </a:r>
             <a:endParaRPr lang="en-US" sz="2000" dirty="0">
               <a:solidFill>
@@ -3767,7 +3767,7 @@
         <p:spPr>
           <a:xfrm>
             <a:off x="1115616" y="1082884"/>
-            <a:ext cx="7956376" cy="830997"/>
+            <a:ext cx="7956376" cy="646331"/>
           </a:xfrm>
           <a:prstGeom prst="rect">
             <a:avLst/>
@@ -3799,7 +3799,7 @@
                 </a:solidFill>
                 <a:latin typeface="Segoe UI" panose="020B0502040204020203" pitchFamily="34" charset="0"/>
               </a:rPr>
-              <a:t>Reporte de material escaneado por proceso </a:t>
+              <a:t>Reporte de Rechazos, </a:t>
             </a:r>
             <a:r>
               <a:rPr lang="es-ES" sz="1200" dirty="0">
@@ -3853,6 +3853,24 @@
                 </a:solidFill>
                 <a:latin typeface="Segoe UI" panose="020B0502040204020203" pitchFamily="34" charset="0"/>
               </a:rPr>
+              <a:t> se </a:t>
+            </a:r>
+            <a:r>
+              <a:rPr lang="en-US" sz="1200" dirty="0" err="1">
+                <a:solidFill>
+                  <a:srgbClr val="222222"/>
+                </a:solidFill>
+                <a:latin typeface="Segoe UI" panose="020B0502040204020203" pitchFamily="34" charset="0"/>
+              </a:rPr>
+              <a:t>puede</a:t>
+            </a:r>
+            <a:r>
+              <a:rPr lang="en-US" sz="1200" dirty="0">
+                <a:solidFill>
+                  <a:srgbClr val="222222"/>
+                </a:solidFill>
+                <a:latin typeface="Segoe UI" panose="020B0502040204020203" pitchFamily="34" charset="0"/>
+              </a:rPr>
               <a:t> </a:t>
             </a:r>
             <a:r>
@@ -3862,7 +3880,7 @@
                 </a:solidFill>
                 <a:latin typeface="Segoe UI" panose="020B0502040204020203" pitchFamily="34" charset="0"/>
               </a:rPr>
-              <a:t>podremos</a:t>
+              <a:t>realizar</a:t>
             </a:r>
             <a:r>
               <a:rPr lang="en-US" sz="1200" dirty="0">
@@ -3871,16 +3889,115 @@
                 </a:solidFill>
                 <a:latin typeface="Segoe UI" panose="020B0502040204020203" pitchFamily="34" charset="0"/>
               </a:rPr>
+              <a:t> la </a:t>
+            </a:r>
+            <a:r>
+              <a:rPr lang="en-US" sz="1200" dirty="0" err="1">
+                <a:solidFill>
+                  <a:srgbClr val="222222"/>
+                </a:solidFill>
+                <a:latin typeface="Segoe UI" panose="020B0502040204020203" pitchFamily="34" charset="0"/>
+              </a:rPr>
+              <a:t>busqueda</a:t>
+            </a:r>
+            <a:r>
+              <a:rPr lang="en-US" sz="1200" dirty="0">
+                <a:solidFill>
+                  <a:srgbClr val="222222"/>
+                </a:solidFill>
+                <a:latin typeface="Segoe UI" panose="020B0502040204020203" pitchFamily="34" charset="0"/>
+              </a:rPr>
+              <a:t> de </a:t>
+            </a:r>
+            <a:r>
+              <a:rPr lang="en-US" sz="1200" dirty="0" err="1">
+                <a:solidFill>
+                  <a:srgbClr val="222222"/>
+                </a:solidFill>
+                <a:latin typeface="Segoe UI" panose="020B0502040204020203" pitchFamily="34" charset="0"/>
+              </a:rPr>
+              <a:t>rechazos</a:t>
+            </a:r>
+            <a:r>
+              <a:rPr lang="en-US" sz="1200" dirty="0">
+                <a:solidFill>
+                  <a:srgbClr val="222222"/>
+                </a:solidFill>
+                <a:latin typeface="Segoe UI" panose="020B0502040204020203" pitchFamily="34" charset="0"/>
+              </a:rPr>
+              <a:t> por un</a:t>
+            </a:r>
+            <a:r>
+              <a:rPr lang="en-US" sz="1200" b="1" dirty="0">
+                <a:solidFill>
+                  <a:srgbClr val="222222"/>
+                </a:solidFill>
+                <a:latin typeface="Segoe UI" panose="020B0502040204020203" pitchFamily="34" charset="0"/>
+              </a:rPr>
               <a:t> </a:t>
             </a:r>
             <a:r>
+              <a:rPr lang="en-US" sz="1200" b="1" dirty="0" err="1">
+                <a:solidFill>
+                  <a:srgbClr val="222222"/>
+                </a:solidFill>
+                <a:latin typeface="Segoe UI" panose="020B0502040204020203" pitchFamily="34" charset="0"/>
+              </a:rPr>
+              <a:t>rango</a:t>
+            </a:r>
+            <a:r>
+              <a:rPr lang="en-US" sz="1200" b="1" dirty="0">
+                <a:solidFill>
+                  <a:srgbClr val="222222"/>
+                </a:solidFill>
+                <a:latin typeface="Segoe UI" panose="020B0502040204020203" pitchFamily="34" charset="0"/>
+              </a:rPr>
+              <a:t> de </a:t>
+            </a:r>
+            <a:r>
+              <a:rPr lang="en-US" sz="1200" b="1" dirty="0" err="1">
+                <a:solidFill>
+                  <a:srgbClr val="222222"/>
+                </a:solidFill>
+                <a:latin typeface="Segoe UI" panose="020B0502040204020203" pitchFamily="34" charset="0"/>
+              </a:rPr>
+              <a:t>fechas</a:t>
+            </a:r>
+            <a:r>
+              <a:rPr lang="en-US" sz="1200" dirty="0">
+                <a:solidFill>
+                  <a:srgbClr val="222222"/>
+                </a:solidFill>
+                <a:latin typeface="Segoe UI" panose="020B0502040204020203" pitchFamily="34" charset="0"/>
+              </a:rPr>
+              <a:t>, </a:t>
+            </a:r>
+            <a:r>
+              <a:rPr lang="en-US" sz="1200" b="1" dirty="0">
+                <a:solidFill>
+                  <a:srgbClr val="222222"/>
+                </a:solidFill>
+                <a:latin typeface="Segoe UI" panose="020B0502040204020203" pitchFamily="34" charset="0"/>
+              </a:rPr>
+              <a:t>Product Category</a:t>
+            </a:r>
+            <a:r>
+              <a:rPr lang="en-US" sz="1200" dirty="0">
+                <a:solidFill>
+                  <a:srgbClr val="222222"/>
+                </a:solidFill>
+                <a:latin typeface="Segoe UI" panose="020B0502040204020203" pitchFamily="34" charset="0"/>
+              </a:rPr>
+              <a:t> o </a:t>
+            </a:r>
+            <a:r>
               <a:rPr lang="en-US" sz="1200" dirty="0" err="1">
                 <a:solidFill>
                   <a:srgbClr val="222222"/>
                 </a:solidFill>
                 <a:latin typeface="Segoe UI" panose="020B0502040204020203" pitchFamily="34" charset="0"/>
               </a:rPr>
-              <a:t>consultar</a:t>
+              <a:t>poniendo</a:t>
             </a:r>
             <a:r>
               <a:rPr lang="en-US" sz="1200" dirty="0">
@@ -3889,7 +4006,7 @@
                 </a:solidFill>
                 <a:latin typeface="Segoe UI" panose="020B0502040204020203" pitchFamily="34" charset="0"/>
               </a:rPr>
-              <a:t> la </a:t>
+              <a:t> </a:t>
             </a:r>
             <a:r>
               <a:rPr lang="en-US" sz="1200" dirty="0" err="1">
@@ -3898,7 +4015,7 @@
                 </a:solidFill>
                 <a:latin typeface="Segoe UI" panose="020B0502040204020203" pitchFamily="34" charset="0"/>
               </a:rPr>
-              <a:t>información</a:t>
+              <a:t>el</a:t>
             </a:r>
             <a:r>
               <a:rPr lang="en-US" sz="1200" dirty="0">
@@ -3910,13 +4027,121 @@
               <a:t> </a:t>
             </a:r>
             <a:r>
+              <a:rPr lang="en-US" sz="1200" b="1" dirty="0" err="1">
+                <a:solidFill>
+                  <a:srgbClr val="222222"/>
+                </a:solidFill>
+                <a:latin typeface="Segoe UI" panose="020B0502040204020203" pitchFamily="34" charset="0"/>
+              </a:rPr>
+              <a:t>Numero</a:t>
+            </a:r>
+            <a:r>
+              <a:rPr lang="en-US" sz="1200" b="1" dirty="0">
+                <a:solidFill>
+                  <a:srgbClr val="222222"/>
+                </a:solidFill>
+                <a:latin typeface="Segoe UI" panose="020B0502040204020203" pitchFamily="34" charset="0"/>
+              </a:rPr>
+              <a:t> de </a:t>
+            </a:r>
+            <a:r>
+              <a:rPr lang="en-US" sz="1200" b="1" dirty="0" err="1">
+                <a:solidFill>
+                  <a:srgbClr val="222222"/>
+                </a:solidFill>
+                <a:latin typeface="Segoe UI" panose="020B0502040204020203" pitchFamily="34" charset="0"/>
+              </a:rPr>
+              <a:t>Parte</a:t>
+            </a:r>
+            <a:r>
+              <a:rPr lang="en-US" sz="1200" b="1" dirty="0">
+                <a:solidFill>
+                  <a:srgbClr val="222222"/>
+                </a:solidFill>
+                <a:latin typeface="Segoe UI" panose="020B0502040204020203" pitchFamily="34" charset="0"/>
+              </a:rPr>
+              <a:t> del </a:t>
+            </a:r>
+            <a:r>
+              <a:rPr lang="en-US" sz="1200" b="1" dirty="0" err="1">
+                <a:solidFill>
+                  <a:srgbClr val="222222"/>
+                </a:solidFill>
+                <a:latin typeface="Segoe UI" panose="020B0502040204020203" pitchFamily="34" charset="0"/>
+              </a:rPr>
+              <a:t>Cliente</a:t>
+            </a:r>
+            <a:r>
+              <a:rPr lang="en-US" sz="1200" dirty="0">
+                <a:solidFill>
+                  <a:srgbClr val="222222"/>
+                </a:solidFill>
+                <a:latin typeface="Segoe UI" panose="020B0502040204020203" pitchFamily="34" charset="0"/>
+              </a:rPr>
+              <a:t>, </a:t>
+            </a:r>
+            <a:r>
+              <a:rPr lang="en-US" sz="1200" b="1" dirty="0">
+                <a:solidFill>
+                  <a:srgbClr val="222222"/>
+                </a:solidFill>
+                <a:latin typeface="Segoe UI" panose="020B0502040204020203" pitchFamily="34" charset="0"/>
+              </a:rPr>
+              <a:t>Serial</a:t>
+            </a:r>
+            <a:r>
+              <a:rPr lang="en-US" sz="1200" dirty="0">
+                <a:solidFill>
+                  <a:srgbClr val="222222"/>
+                </a:solidFill>
+                <a:latin typeface="Segoe UI" panose="020B0502040204020203" pitchFamily="34" charset="0"/>
+              </a:rPr>
+              <a:t>, </a:t>
+            </a:r>
+            <a:r>
+              <a:rPr lang="en-US" sz="1200" b="1" dirty="0">
+                <a:solidFill>
+                  <a:srgbClr val="222222"/>
+                </a:solidFill>
+                <a:latin typeface="Segoe UI" panose="020B0502040204020203" pitchFamily="34" charset="0"/>
+              </a:rPr>
+              <a:t>Orden</a:t>
+            </a:r>
+            <a:r>
+              <a:rPr lang="en-US" sz="1200" dirty="0">
+                <a:solidFill>
+                  <a:srgbClr val="222222"/>
+                </a:solidFill>
+                <a:latin typeface="Segoe UI" panose="020B0502040204020203" pitchFamily="34" charset="0"/>
+              </a:rPr>
+              <a:t>, </a:t>
+            </a:r>
+            <a:r>
+              <a:rPr lang="en-US" sz="1200" b="1" dirty="0" err="1">
+                <a:solidFill>
+                  <a:srgbClr val="222222"/>
+                </a:solidFill>
+                <a:latin typeface="Segoe UI" panose="020B0502040204020203" pitchFamily="34" charset="0"/>
+              </a:rPr>
+              <a:t>Estación</a:t>
+            </a:r>
+            <a:r>
+              <a:rPr lang="en-US" sz="1200" dirty="0">
+                <a:solidFill>
+                  <a:srgbClr val="222222"/>
+                </a:solidFill>
+                <a:latin typeface="Segoe UI" panose="020B0502040204020203" pitchFamily="34" charset="0"/>
+              </a:rPr>
+              <a:t> </a:t>
+            </a:r>
+            <a:r>
               <a:rPr lang="en-US" sz="1200" dirty="0" err="1">
                 <a:solidFill>
                   <a:srgbClr val="222222"/>
                 </a:solidFill>
                 <a:latin typeface="Segoe UI" panose="020B0502040204020203" pitchFamily="34" charset="0"/>
               </a:rPr>
-              <a:t>detalla</a:t>
+              <a:t>en</a:t>
             </a:r>
             <a:r>
               <a:rPr lang="en-US" sz="1200" dirty="0">
@@ -3925,7 +4150,7 @@
                 </a:solidFill>
                 <a:latin typeface="Segoe UI" panose="020B0502040204020203" pitchFamily="34" charset="0"/>
               </a:rPr>
-              <a:t> de la </a:t>
+              <a:t> </a:t>
             </a:r>
             <a:r>
               <a:rPr lang="en-US" sz="1200" dirty="0" err="1">
@@ -3934,7 +4159,7 @@
                 </a:solidFill>
                 <a:latin typeface="Segoe UI" panose="020B0502040204020203" pitchFamily="34" charset="0"/>
               </a:rPr>
-              <a:t>cantidad</a:t>
+              <a:t>el</a:t>
             </a:r>
             <a:r>
               <a:rPr lang="en-US" sz="1200" dirty="0">
@@ -3943,7 +4168,16 @@
                 </a:solidFill>
                 <a:latin typeface="Segoe UI" panose="020B0502040204020203" pitchFamily="34" charset="0"/>
               </a:rPr>
-              <a:t> de</a:t>
+              <a:t> campo </a:t>
+            </a:r>
+            <a:r>
+              <a:rPr lang="en-US" sz="1200" b="1" dirty="0" err="1">
+                <a:solidFill>
+                  <a:srgbClr val="222222"/>
+                </a:solidFill>
+                <a:latin typeface="Segoe UI" panose="020B0502040204020203" pitchFamily="34" charset="0"/>
+              </a:rPr>
+              <a:t>Buscar</a:t>
             </a:r>
             <a:r>
               <a:rPr lang="en-US" sz="1200" b="1" dirty="0">
@@ -3952,16 +4186,16 @@
                 </a:solidFill>
                 <a:latin typeface="Segoe UI" panose="020B0502040204020203" pitchFamily="34" charset="0"/>
               </a:rPr>
-              <a:t> Kits/</a:t>
-            </a:r>
-            <a:r>
-              <a:rPr lang="en-US" sz="1200" b="1" dirty="0" err="1">
-                <a:solidFill>
-                  <a:srgbClr val="222222"/>
-                </a:solidFill>
-                <a:latin typeface="Segoe UI" panose="020B0502040204020203" pitchFamily="34" charset="0"/>
-              </a:rPr>
-              <a:t>Patrones</a:t>
+              <a:t> </a:t>
+            </a:r>
+            <a:r>
+              <a:rPr lang="en-US" sz="1200" dirty="0">
+                <a:solidFill>
+                  <a:srgbClr val="222222"/>
+                </a:solidFill>
+                <a:latin typeface="Segoe UI" panose="020B0502040204020203" pitchFamily="34" charset="0"/>
+              </a:rPr>
+              <a:t>y</a:t>
             </a:r>
             <a:r>
               <a:rPr lang="en-US" sz="1200" b="1" dirty="0">
@@ -3970,250 +4204,7 @@
                 </a:solidFill>
                 <a:latin typeface="Segoe UI" panose="020B0502040204020203" pitchFamily="34" charset="0"/>
               </a:rPr>
-              <a:t>/</a:t>
-            </a:r>
-            <a:r>
-              <a:rPr lang="en-US" sz="1200" b="1" dirty="0" err="1">
-                <a:solidFill>
-                  <a:srgbClr val="222222"/>
-                </a:solidFill>
-                <a:latin typeface="Segoe UI" panose="020B0502040204020203" pitchFamily="34" charset="0"/>
-              </a:rPr>
-              <a:t>Piezas</a:t>
-            </a:r>
-            <a:r>
-              <a:rPr lang="en-US" sz="1200" b="1" dirty="0">
-                <a:solidFill>
-                  <a:srgbClr val="222222"/>
-                </a:solidFill>
-                <a:latin typeface="Segoe UI" panose="020B0502040204020203" pitchFamily="34" charset="0"/>
-              </a:rPr>
               <a:t> </a:t>
-            </a:r>
-            <a:r>
-              <a:rPr lang="en-US" sz="1200" dirty="0" err="1">
-                <a:solidFill>
-                  <a:srgbClr val="222222"/>
-                </a:solidFill>
-                <a:latin typeface="Segoe UI" panose="020B0502040204020203" pitchFamily="34" charset="0"/>
-              </a:rPr>
-              <a:t>escaneados</a:t>
-            </a:r>
-            <a:r>
-              <a:rPr lang="en-US" sz="1200" dirty="0">
-                <a:solidFill>
-                  <a:srgbClr val="222222"/>
-                </a:solidFill>
-                <a:latin typeface="Segoe UI" panose="020B0502040204020203" pitchFamily="34" charset="0"/>
-              </a:rPr>
-              <a:t> </a:t>
-            </a:r>
-            <a:r>
-              <a:rPr lang="en-US" sz="1200" dirty="0" err="1">
-                <a:solidFill>
-                  <a:srgbClr val="222222"/>
-                </a:solidFill>
-                <a:latin typeface="Segoe UI" panose="020B0502040204020203" pitchFamily="34" charset="0"/>
-              </a:rPr>
-              <a:t>en</a:t>
-            </a:r>
-            <a:r>
-              <a:rPr lang="en-US" sz="1200" dirty="0">
-                <a:solidFill>
-                  <a:srgbClr val="222222"/>
-                </a:solidFill>
-                <a:latin typeface="Segoe UI" panose="020B0502040204020203" pitchFamily="34" charset="0"/>
-              </a:rPr>
-              <a:t> </a:t>
-            </a:r>
-            <a:r>
-              <a:rPr lang="en-US" sz="1200" dirty="0" err="1">
-                <a:solidFill>
-                  <a:srgbClr val="222222"/>
-                </a:solidFill>
-                <a:latin typeface="Segoe UI" panose="020B0502040204020203" pitchFamily="34" charset="0"/>
-              </a:rPr>
-              <a:t>cada</a:t>
-            </a:r>
-            <a:r>
-              <a:rPr lang="en-US" sz="1200" dirty="0">
-                <a:solidFill>
-                  <a:srgbClr val="222222"/>
-                </a:solidFill>
-                <a:latin typeface="Segoe UI" panose="020B0502040204020203" pitchFamily="34" charset="0"/>
-              </a:rPr>
-              <a:t> uno de los </a:t>
-            </a:r>
-            <a:r>
-              <a:rPr lang="en-US" sz="1200" dirty="0" err="1">
-                <a:solidFill>
-                  <a:srgbClr val="222222"/>
-                </a:solidFill>
-                <a:latin typeface="Segoe UI" panose="020B0502040204020203" pitchFamily="34" charset="0"/>
-              </a:rPr>
-              <a:t>procesos</a:t>
-            </a:r>
-            <a:r>
-              <a:rPr lang="en-US" sz="1200" dirty="0">
-                <a:solidFill>
-                  <a:srgbClr val="222222"/>
-                </a:solidFill>
-                <a:latin typeface="Segoe UI" panose="020B0502040204020203" pitchFamily="34" charset="0"/>
-              </a:rPr>
-              <a:t>, las </a:t>
-            </a:r>
-            <a:r>
-              <a:rPr lang="en-US" sz="1200" dirty="0" err="1">
-                <a:solidFill>
-                  <a:srgbClr val="222222"/>
-                </a:solidFill>
-                <a:latin typeface="Segoe UI" panose="020B0502040204020203" pitchFamily="34" charset="0"/>
-              </a:rPr>
-              <a:t>busquedas</a:t>
-            </a:r>
-            <a:r>
-              <a:rPr lang="en-US" sz="1200" dirty="0">
-                <a:solidFill>
-                  <a:srgbClr val="222222"/>
-                </a:solidFill>
-                <a:latin typeface="Segoe UI" panose="020B0502040204020203" pitchFamily="34" charset="0"/>
-              </a:rPr>
-              <a:t> </a:t>
-            </a:r>
-            <a:r>
-              <a:rPr lang="en-US" sz="1200" dirty="0" err="1">
-                <a:solidFill>
-                  <a:srgbClr val="222222"/>
-                </a:solidFill>
-                <a:latin typeface="Segoe UI" panose="020B0502040204020203" pitchFamily="34" charset="0"/>
-              </a:rPr>
-              <a:t>pueden</a:t>
-            </a:r>
-            <a:r>
-              <a:rPr lang="en-US" sz="1200" dirty="0">
-                <a:solidFill>
-                  <a:srgbClr val="222222"/>
-                </a:solidFill>
-                <a:latin typeface="Segoe UI" panose="020B0502040204020203" pitchFamily="34" charset="0"/>
-              </a:rPr>
-              <a:t> </a:t>
-            </a:r>
-            <a:r>
-              <a:rPr lang="en-US" sz="1200" dirty="0" err="1">
-                <a:solidFill>
-                  <a:srgbClr val="222222"/>
-                </a:solidFill>
-                <a:latin typeface="Segoe UI" panose="020B0502040204020203" pitchFamily="34" charset="0"/>
-              </a:rPr>
-              <a:t>realizarse</a:t>
-            </a:r>
-            <a:r>
-              <a:rPr lang="en-US" sz="1200" dirty="0">
-                <a:solidFill>
-                  <a:srgbClr val="222222"/>
-                </a:solidFill>
-                <a:latin typeface="Segoe UI" panose="020B0502040204020203" pitchFamily="34" charset="0"/>
-              </a:rPr>
-              <a:t> por un</a:t>
-            </a:r>
-            <a:r>
-              <a:rPr lang="en-US" sz="1200" b="1" dirty="0">
-                <a:solidFill>
-                  <a:srgbClr val="222222"/>
-                </a:solidFill>
-                <a:latin typeface="Segoe UI" panose="020B0502040204020203" pitchFamily="34" charset="0"/>
-              </a:rPr>
-              <a:t> </a:t>
-            </a:r>
-            <a:r>
-              <a:rPr lang="en-US" sz="1200" b="1" dirty="0" err="1">
-                <a:solidFill>
-                  <a:srgbClr val="222222"/>
-                </a:solidFill>
-                <a:latin typeface="Segoe UI" panose="020B0502040204020203" pitchFamily="34" charset="0"/>
-              </a:rPr>
-              <a:t>rango</a:t>
-            </a:r>
-            <a:r>
-              <a:rPr lang="en-US" sz="1200" b="1" dirty="0">
-                <a:solidFill>
-                  <a:srgbClr val="222222"/>
-                </a:solidFill>
-                <a:latin typeface="Segoe UI" panose="020B0502040204020203" pitchFamily="34" charset="0"/>
-              </a:rPr>
-              <a:t> de </a:t>
-            </a:r>
-            <a:r>
-              <a:rPr lang="en-US" sz="1200" b="1" dirty="0" err="1">
-                <a:solidFill>
-                  <a:srgbClr val="222222"/>
-                </a:solidFill>
-                <a:latin typeface="Segoe UI" panose="020B0502040204020203" pitchFamily="34" charset="0"/>
-              </a:rPr>
-              <a:t>fechas</a:t>
-            </a:r>
-            <a:r>
-              <a:rPr lang="en-US" sz="1200" dirty="0">
-                <a:solidFill>
-                  <a:srgbClr val="222222"/>
-                </a:solidFill>
-                <a:latin typeface="Segoe UI" panose="020B0502040204020203" pitchFamily="34" charset="0"/>
-              </a:rPr>
-              <a:t>, </a:t>
-            </a:r>
-            <a:r>
-              <a:rPr lang="en-US" sz="1200" b="1" dirty="0" err="1">
-                <a:solidFill>
-                  <a:srgbClr val="222222"/>
-                </a:solidFill>
-                <a:latin typeface="Segoe UI" panose="020B0502040204020203" pitchFamily="34" charset="0"/>
-              </a:rPr>
-              <a:t>Cliente</a:t>
-            </a:r>
-            <a:r>
-              <a:rPr lang="en-US" sz="1200" dirty="0">
-                <a:solidFill>
-                  <a:srgbClr val="222222"/>
-                </a:solidFill>
-                <a:latin typeface="Segoe UI" panose="020B0502040204020203" pitchFamily="34" charset="0"/>
-              </a:rPr>
-              <a:t>, </a:t>
-            </a:r>
-            <a:r>
-              <a:rPr lang="en-US" sz="1200" b="1" dirty="0" err="1">
-                <a:solidFill>
-                  <a:srgbClr val="222222"/>
-                </a:solidFill>
-                <a:latin typeface="Segoe UI" panose="020B0502040204020203" pitchFamily="34" charset="0"/>
-              </a:rPr>
-              <a:t>Proceso</a:t>
-            </a:r>
-            <a:r>
-              <a:rPr lang="en-US" sz="1200" dirty="0">
-                <a:solidFill>
-                  <a:srgbClr val="222222"/>
-                </a:solidFill>
-                <a:latin typeface="Segoe UI" panose="020B0502040204020203" pitchFamily="34" charset="0"/>
-              </a:rPr>
-              <a:t> y </a:t>
-            </a:r>
-            <a:r>
-              <a:rPr lang="en-US" sz="1200" b="1" dirty="0" err="1">
-                <a:solidFill>
-                  <a:srgbClr val="222222"/>
-                </a:solidFill>
-                <a:latin typeface="Segoe UI" panose="020B0502040204020203" pitchFamily="34" charset="0"/>
-              </a:rPr>
-              <a:t>Turno</a:t>
-            </a:r>
-            <a:r>
-              <a:rPr lang="en-US" sz="1200" b="1" dirty="0">
-                <a:solidFill>
-                  <a:srgbClr val="222222"/>
-                </a:solidFill>
-                <a:latin typeface="Segoe UI" panose="020B0502040204020203" pitchFamily="34" charset="0"/>
-              </a:rPr>
-              <a:t>, </a:t>
             </a:r>
             <a:r>
               <a:rPr lang="en-US" sz="1200" dirty="0" err="1">
@@ -4351,42 +4342,6 @@
           </a:p>
         </p:txBody>
       </p:sp>
-      <p:pic>
-        <p:nvPicPr>
-          <p:cNvPr id="11" name="Imagen 10" descr="Interfaz de usuario gráfica, Aplicación, Tabla, Excel&#10;&#10;Descripción generada automáticamente">
-            <a:extLst>
-              <a:ext uri="{FF2B5EF4-FFF2-40B4-BE49-F238E27FC236}">
-                <a16:creationId xmlns:a16="http://schemas.microsoft.com/office/drawing/2014/main" id="{24AAC71E-DE7E-4A99-A211-CAE26A5A713C}"/>
-              </a:ext>
-            </a:extLst>
-          </p:cNvPr>
-          <p:cNvPicPr>
-            <a:picLocks noChangeAspect="1"/>
-          </p:cNvPicPr>
-          <p:nvPr/>
-        </p:nvPicPr>
-        <p:blipFill>
-          <a:blip r:embed="rId2">
-            <a:extLst>
-              <a:ext uri="{28A0092B-C50C-407E-A947-70E740481C1C}">
-                <a14:useLocalDpi xmlns:a14="http://schemas.microsoft.com/office/drawing/2010/main" val="0"/>
-              </a:ext>
-            </a:extLst>
-          </a:blip>
-          <a:stretch>
-            <a:fillRect/>
-          </a:stretch>
-        </p:blipFill>
-        <p:spPr>
-          <a:xfrm>
-            <a:off x="1115616" y="1845028"/>
-            <a:ext cx="7956376" cy="4968348"/>
-          </a:xfrm>
-          <a:prstGeom prst="rect">
-            <a:avLst/>
-          </a:prstGeom>
-        </p:spPr>
-      </p:pic>
       <p:sp>
         <p:nvSpPr>
           <p:cNvPr id="12" name="Rectángulo 11">
@@ -4439,6 +4394,42 @@
           </a:p>
         </p:txBody>
       </p:sp>
+      <p:pic>
+        <p:nvPicPr>
+          <p:cNvPr id="3" name="Imagen 2" descr="Interfaz de usuario gráfica, Texto, Aplicación&#10;&#10;Descripción generada automáticamente">
+            <a:extLst>
+              <a:ext uri="{FF2B5EF4-FFF2-40B4-BE49-F238E27FC236}">
+                <a16:creationId xmlns:a16="http://schemas.microsoft.com/office/drawing/2014/main" id="{6ECA891F-0C90-438B-A012-EE7DF58793FC}"/>
+              </a:ext>
+            </a:extLst>
+          </p:cNvPr>
+          <p:cNvPicPr>
+            <a:picLocks noChangeAspect="1"/>
+          </p:cNvPicPr>
+          <p:nvPr/>
+        </p:nvPicPr>
+        <p:blipFill>
+          <a:blip r:embed="rId2">
+            <a:extLst>
+              <a:ext uri="{28A0092B-C50C-407E-A947-70E740481C1C}">
+                <a14:useLocalDpi xmlns:a14="http://schemas.microsoft.com/office/drawing/2010/main" val="0"/>
+              </a:ext>
+            </a:extLst>
+          </a:blip>
+          <a:stretch>
+            <a:fillRect/>
+          </a:stretch>
+        </p:blipFill>
+        <p:spPr>
+          <a:xfrm>
+            <a:off x="1087408" y="1729216"/>
+            <a:ext cx="7984584" cy="5087112"/>
+          </a:xfrm>
+          <a:prstGeom prst="rect">
+            <a:avLst/>
+          </a:prstGeom>
+        </p:spPr>
+      </p:pic>
     </p:spTree>
     <p:extLst>
       <p:ext uri="{BB962C8B-B14F-4D97-AF65-F5344CB8AC3E}">

</xml_diff>